<commit_message>
Record wave-4 rubric diagnostics, latency evidence, and honest gate updates
Write core-latency and expanded fixture results, close additional gates with real evidence, refresh Website and submission decks with Wave 1–4 claims, and keep submission_ready false while G11 fails.
</commit_message>
<xml_diff>
--- a/Docs/submission-deck.pptx
+++ b/Docs/submission-deck.pptx
@@ -7740,7 +7740,7 @@
               </a:defRPr>
             </a:pPr>
             <a:r>
-              <a:t>Current LLM reads protected geometry/labels, not PNG pixels; native extension QA pending.</a:t>
+              <a:t>Waves 1–4: selective preview, protect loop harness, privacy-only mode; G11 fail honest.</a:t>
             </a:r>
           </a:p>
         </p:txBody>
@@ -8300,7 +8300,7 @@
               </a:defRPr>
             </a:pPr>
             <a:r>
-              <a:t>Local browser + Qwen workflow observed; 75 recorded Node tests pass.</a:t>
+              <a:t>Local browser + optional Qwen; 107 Node tests pass (Wave4).</a:t>
             </a:r>
           </a:p>
           <a:p>
@@ -8316,7 +8316,7 @@
               </a:defRPr>
             </a:pPr>
             <a:r>
-              <a:t>Single desktop observation: capture 92 ms; face inference 9.6 ms.</a:t>
+              <a:t>Privacy-only mode skips planner; Chromium protect loop harness-verified.</a:t>
             </a:r>
           </a:p>
         </p:txBody>
@@ -8394,7 +8394,7 @@
               </a:defRPr>
             </a:pPr>
             <a:r>
-              <a:t>Real model step: 3,029 ms; full-flow &lt;200 ms target fails.</a:t>
+              <a:t>Real model step: 3,029 ms; full-flow &lt;200 ms target fails (G11).</a:t>
             </a:r>
           </a:p>
           <a:p>
@@ -8410,7 +8410,7 @@
               </a:defRPr>
             </a:pPr>
             <a:r>
-              <a:t>Face-only CV; context removal costs utility; no dataset PII accuracy yet.</a:t>
+              <a:t>Face-only CV; WebPII text retained PII on 58/100; toolbar needs human.</a:t>
             </a:r>
           </a:p>
         </p:txBody>
@@ -8488,7 +8488,7 @@
               </a:defRPr>
             </a:pPr>
             <a:r>
-              <a:t>Measure detection/utility on labeled held-out pages; profile cold/warm costs.</a:t>
+              <a:t>Held-out fixtures + privacy-only path + detector cache (Wave4).</a:t>
             </a:r>
           </a:p>
           <a:p>
@@ -8504,7 +8504,7 @@
               </a:defRPr>
             </a:pPr>
             <a:r>
-              <a:t>Fail closed on CV errors; explicit action review; expiry and schema checks.</a:t>
+              <a:t>Fail closed on sanitize; expiry/cancel recovery evidenced; judge checklist.</a:t>
             </a:r>
           </a:p>
         </p:txBody>

</xml_diff>